<commit_message>
feat: week02 chapter2 실습 코드 추가
</commit_message>
<xml_diff>
--- a/week02/1장.pptx
+++ b/week02/1장.pptx
@@ -211,7 +211,7 @@
           <a:p>
             <a:fld id="{EB29CB68-1941-4906-AC12-2D09C79E6FC6}" type="datetimeFigureOut">
               <a:rPr lang="ko-KR" altLang="en-US" smtClean="0"/>
-              <a:t>2026-04-09</a:t>
+              <a:t>2026-04-15</a:t>
             </a:fld>
             <a:endParaRPr lang="ko-KR" altLang="en-US"/>
           </a:p>
@@ -709,7 +709,7 @@
           <a:p>
             <a:fld id="{A59215A9-734E-4AD3-8910-5EED93001A62}" type="datetimeFigureOut">
               <a:rPr lang="ko-KR" altLang="en-US" smtClean="0"/>
-              <a:t>2026-04-09</a:t>
+              <a:t>2026-04-15</a:t>
             </a:fld>
             <a:endParaRPr lang="ko-KR" altLang="en-US"/>
           </a:p>
@@ -907,7 +907,7 @@
           <a:p>
             <a:fld id="{A59215A9-734E-4AD3-8910-5EED93001A62}" type="datetimeFigureOut">
               <a:rPr lang="ko-KR" altLang="en-US" smtClean="0"/>
-              <a:t>2026-04-09</a:t>
+              <a:t>2026-04-15</a:t>
             </a:fld>
             <a:endParaRPr lang="ko-KR" altLang="en-US"/>
           </a:p>
@@ -1115,7 +1115,7 @@
           <a:p>
             <a:fld id="{A59215A9-734E-4AD3-8910-5EED93001A62}" type="datetimeFigureOut">
               <a:rPr lang="ko-KR" altLang="en-US" smtClean="0"/>
-              <a:t>2026-04-09</a:t>
+              <a:t>2026-04-15</a:t>
             </a:fld>
             <a:endParaRPr lang="ko-KR" altLang="en-US"/>
           </a:p>
@@ -1319,7 +1319,7 @@
           <a:p>
             <a:fld id="{A59215A9-734E-4AD3-8910-5EED93001A62}" type="datetimeFigureOut">
               <a:rPr lang="ko-KR" altLang="en-US" smtClean="0"/>
-              <a:t>2026-04-09</a:t>
+              <a:t>2026-04-15</a:t>
             </a:fld>
             <a:endParaRPr lang="ko-KR" altLang="en-US"/>
           </a:p>
@@ -1594,7 +1594,7 @@
           <a:p>
             <a:fld id="{A59215A9-734E-4AD3-8910-5EED93001A62}" type="datetimeFigureOut">
               <a:rPr lang="ko-KR" altLang="en-US" smtClean="0"/>
-              <a:t>2026-04-09</a:t>
+              <a:t>2026-04-15</a:t>
             </a:fld>
             <a:endParaRPr lang="ko-KR" altLang="en-US"/>
           </a:p>
@@ -1859,7 +1859,7 @@
           <a:p>
             <a:fld id="{A59215A9-734E-4AD3-8910-5EED93001A62}" type="datetimeFigureOut">
               <a:rPr lang="ko-KR" altLang="en-US" smtClean="0"/>
-              <a:t>2026-04-09</a:t>
+              <a:t>2026-04-15</a:t>
             </a:fld>
             <a:endParaRPr lang="ko-KR" altLang="en-US"/>
           </a:p>
@@ -2271,7 +2271,7 @@
           <a:p>
             <a:fld id="{A59215A9-734E-4AD3-8910-5EED93001A62}" type="datetimeFigureOut">
               <a:rPr lang="ko-KR" altLang="en-US" smtClean="0"/>
-              <a:t>2026-04-09</a:t>
+              <a:t>2026-04-15</a:t>
             </a:fld>
             <a:endParaRPr lang="ko-KR" altLang="en-US"/>
           </a:p>
@@ -2412,7 +2412,7 @@
           <a:p>
             <a:fld id="{A59215A9-734E-4AD3-8910-5EED93001A62}" type="datetimeFigureOut">
               <a:rPr lang="ko-KR" altLang="en-US" smtClean="0"/>
-              <a:t>2026-04-09</a:t>
+              <a:t>2026-04-15</a:t>
             </a:fld>
             <a:endParaRPr lang="ko-KR" altLang="en-US"/>
           </a:p>
@@ -2525,7 +2525,7 @@
           <a:p>
             <a:fld id="{A59215A9-734E-4AD3-8910-5EED93001A62}" type="datetimeFigureOut">
               <a:rPr lang="ko-KR" altLang="en-US" smtClean="0"/>
-              <a:t>2026-04-09</a:t>
+              <a:t>2026-04-15</a:t>
             </a:fld>
             <a:endParaRPr lang="ko-KR" altLang="en-US"/>
           </a:p>
@@ -2836,7 +2836,7 @@
           <a:p>
             <a:fld id="{A59215A9-734E-4AD3-8910-5EED93001A62}" type="datetimeFigureOut">
               <a:rPr lang="ko-KR" altLang="en-US" smtClean="0"/>
-              <a:t>2026-04-09</a:t>
+              <a:t>2026-04-15</a:t>
             </a:fld>
             <a:endParaRPr lang="ko-KR" altLang="en-US"/>
           </a:p>
@@ -3124,7 +3124,7 @@
           <a:p>
             <a:fld id="{A59215A9-734E-4AD3-8910-5EED93001A62}" type="datetimeFigureOut">
               <a:rPr lang="ko-KR" altLang="en-US" smtClean="0"/>
-              <a:t>2026-04-09</a:t>
+              <a:t>2026-04-15</a:t>
             </a:fld>
             <a:endParaRPr lang="ko-KR" altLang="en-US"/>
           </a:p>
@@ -3368,7 +3368,7 @@
           <a:p>
             <a:fld id="{A59215A9-734E-4AD3-8910-5EED93001A62}" type="datetimeFigureOut">
               <a:rPr lang="ko-KR" altLang="en-US" smtClean="0"/>
-              <a:t>2026-04-09</a:t>
+              <a:t>2026-04-15</a:t>
             </a:fld>
             <a:endParaRPr lang="ko-KR" altLang="en-US"/>
           </a:p>
@@ -9400,7 +9400,7 @@
               <a:t>in </a:t>
             </a:r>
             <a:r>
-              <a:rPr lang="en-US" altLang="ko-KR" sz="1800" dirty="0">
+              <a:rPr lang="en-US" altLang="ko-KR" sz="1800" u="sng" dirty="0">
                 <a:solidFill>
                   <a:srgbClr val="000000"/>
                 </a:solidFill>
@@ -9411,7 +9411,7 @@
               <a:t>list</a:t>
             </a:r>
             <a:r>
-              <a:rPr lang="en-US" altLang="ko-KR" sz="1800" dirty="0">
+              <a:rPr lang="en-US" altLang="ko-KR" sz="1800" u="sng" dirty="0">
                 <a:solidFill>
                   <a:srgbClr val="080808"/>
                 </a:solidFill>
@@ -9422,7 +9422,7 @@
               <a:t>) {</a:t>
             </a:r>
             <a:br>
-              <a:rPr lang="en-US" altLang="ko-KR" sz="1800" dirty="0">
+              <a:rPr lang="en-US" altLang="ko-KR" sz="1800" u="sng" dirty="0">
                 <a:solidFill>
                   <a:srgbClr val="080808"/>
                 </a:solidFill>
@@ -9432,7 +9432,7 @@
               </a:rPr>
             </a:br>
             <a:r>
-              <a:rPr lang="en-US" altLang="ko-KR" sz="1800" dirty="0">
+              <a:rPr lang="en-US" altLang="ko-KR" sz="1800" u="sng" dirty="0">
                 <a:solidFill>
                   <a:srgbClr val="080808"/>
                 </a:solidFill>
@@ -9443,7 +9443,7 @@
               <a:t>    </a:t>
             </a:r>
             <a:r>
-              <a:rPr lang="en-US" altLang="ko-KR" sz="1800" dirty="0">
+              <a:rPr lang="en-US" altLang="ko-KR" sz="1800" u="sng" dirty="0">
                 <a:solidFill>
                   <a:srgbClr val="0033B3"/>
                 </a:solidFill>
@@ -9454,7 +9454,7 @@
               <a:t>if </a:t>
             </a:r>
             <a:r>
-              <a:rPr lang="en-US" altLang="ko-KR" sz="1800" dirty="0">
+              <a:rPr lang="en-US" altLang="ko-KR" sz="1800" u="sng" dirty="0">
                 <a:solidFill>
                   <a:srgbClr val="080808"/>
                 </a:solidFill>
@@ -9465,7 +9465,7 @@
               <a:t>(</a:t>
             </a:r>
             <a:r>
-              <a:rPr lang="en-US" altLang="ko-KR" sz="1800" dirty="0" err="1">
+              <a:rPr lang="en-US" altLang="ko-KR" sz="1800" u="sng" dirty="0" err="1">
                 <a:solidFill>
                   <a:srgbClr val="000000"/>
                 </a:solidFill>
@@ -9476,7 +9476,7 @@
               <a:t>i</a:t>
             </a:r>
             <a:r>
-              <a:rPr lang="en-US" altLang="ko-KR" sz="1800" dirty="0">
+              <a:rPr lang="en-US" altLang="ko-KR" sz="1800" u="sng" dirty="0">
                 <a:solidFill>
                   <a:srgbClr val="000000"/>
                 </a:solidFill>
@@ -9487,7 +9487,7 @@
               <a:t> </a:t>
             </a:r>
             <a:r>
-              <a:rPr lang="en-US" altLang="ko-KR" sz="1800" dirty="0">
+              <a:rPr lang="en-US" altLang="ko-KR" sz="1800" u="sng" dirty="0">
                 <a:solidFill>
                   <a:srgbClr val="080808"/>
                 </a:solidFill>
@@ -9498,7 +9498,7 @@
               <a:t>* </a:t>
             </a:r>
             <a:r>
-              <a:rPr lang="en-US" altLang="ko-KR" sz="1800" dirty="0">
+              <a:rPr lang="en-US" altLang="ko-KR" sz="1800" u="sng" dirty="0">
                 <a:solidFill>
                   <a:srgbClr val="1750EB"/>
                 </a:solidFill>
@@ -9509,7 +9509,7 @@
               <a:t>2 </a:t>
             </a:r>
             <a:r>
-              <a:rPr lang="en-US" altLang="ko-KR" sz="1800" dirty="0">
+              <a:rPr lang="en-US" altLang="ko-KR" sz="1800" u="sng" dirty="0">
                 <a:solidFill>
                   <a:srgbClr val="080808"/>
                 </a:solidFill>
@@ -9520,7 +9520,7 @@
               <a:t>&gt; </a:t>
             </a:r>
             <a:r>
-              <a:rPr lang="en-US" altLang="ko-KR" sz="1800" dirty="0">
+              <a:rPr lang="en-US" altLang="ko-KR" sz="1800" u="sng" dirty="0">
                 <a:solidFill>
                   <a:srgbClr val="1750EB"/>
                 </a:solidFill>
@@ -9531,7 +9531,7 @@
               <a:t>2</a:t>
             </a:r>
             <a:r>
-              <a:rPr lang="en-US" altLang="ko-KR" sz="1800" dirty="0">
+              <a:rPr lang="en-US" altLang="ko-KR" sz="1800" u="sng" dirty="0">
                 <a:solidFill>
                   <a:srgbClr val="080808"/>
                 </a:solidFill>
@@ -9542,7 +9542,7 @@
               <a:t>) {</a:t>
             </a:r>
             <a:br>
-              <a:rPr lang="en-US" altLang="ko-KR" sz="1800" dirty="0">
+              <a:rPr lang="en-US" altLang="ko-KR" sz="1800" u="sng" dirty="0">
                 <a:solidFill>
                   <a:srgbClr val="080808"/>
                 </a:solidFill>
@@ -9552,7 +9552,7 @@
               </a:rPr>
             </a:br>
             <a:r>
-              <a:rPr lang="en-US" altLang="ko-KR" sz="1800" dirty="0">
+              <a:rPr lang="en-US" altLang="ko-KR" sz="1800" u="sng" dirty="0">
                 <a:solidFill>
                   <a:srgbClr val="080808"/>
                 </a:solidFill>
@@ -9563,7 +9563,7 @@
               <a:t>        </a:t>
             </a:r>
             <a:r>
-              <a:rPr lang="en-US" altLang="ko-KR" sz="1800" dirty="0" err="1">
+              <a:rPr lang="en-US" altLang="ko-KR" sz="1800" u="sng" dirty="0" err="1">
                 <a:solidFill>
                   <a:srgbClr val="000000"/>
                 </a:solidFill>
@@ -9574,7 +9574,7 @@
               <a:t>temp</a:t>
             </a:r>
             <a:r>
-              <a:rPr lang="en-US" altLang="ko-KR" sz="1800" dirty="0" err="1">
+              <a:rPr lang="en-US" altLang="ko-KR" sz="1800" u="sng" dirty="0" err="1">
                 <a:solidFill>
                   <a:srgbClr val="080808"/>
                 </a:solidFill>
@@ -9585,7 +9585,7 @@
               <a:t>.add</a:t>
             </a:r>
             <a:r>
-              <a:rPr lang="en-US" altLang="ko-KR" sz="1800" dirty="0">
+              <a:rPr lang="en-US" altLang="ko-KR" sz="1800" u="sng" dirty="0">
                 <a:solidFill>
                   <a:srgbClr val="080808"/>
                 </a:solidFill>
@@ -9596,7 +9596,7 @@
               <a:t>(</a:t>
             </a:r>
             <a:r>
-              <a:rPr lang="en-US" altLang="ko-KR" sz="1800" dirty="0" err="1">
+              <a:rPr lang="en-US" altLang="ko-KR" sz="1800" u="sng" dirty="0" err="1">
                 <a:solidFill>
                   <a:srgbClr val="000000"/>
                 </a:solidFill>
@@ -9607,7 +9607,7 @@
               <a:t>i</a:t>
             </a:r>
             <a:r>
-              <a:rPr lang="en-US" altLang="ko-KR" sz="1800" dirty="0">
+              <a:rPr lang="en-US" altLang="ko-KR" sz="1800" u="sng" dirty="0">
                 <a:solidFill>
                   <a:srgbClr val="000000"/>
                 </a:solidFill>
@@ -9618,7 +9618,7 @@
               <a:t> </a:t>
             </a:r>
             <a:r>
-              <a:rPr lang="en-US" altLang="ko-KR" sz="1800" dirty="0">
+              <a:rPr lang="en-US" altLang="ko-KR" sz="1800" u="sng" dirty="0">
                 <a:solidFill>
                   <a:srgbClr val="080808"/>
                 </a:solidFill>
@@ -9629,7 +9629,7 @@
               <a:t>* </a:t>
             </a:r>
             <a:r>
-              <a:rPr lang="en-US" altLang="ko-KR" sz="1800" dirty="0">
+              <a:rPr lang="en-US" altLang="ko-KR" sz="1800" u="sng" dirty="0">
                 <a:solidFill>
                   <a:srgbClr val="1750EB"/>
                 </a:solidFill>
@@ -9640,7 +9640,7 @@
               <a:t>2</a:t>
             </a:r>
             <a:r>
-              <a:rPr lang="en-US" altLang="ko-KR" sz="1800" dirty="0">
+              <a:rPr lang="en-US" altLang="ko-KR" sz="1800" u="sng" dirty="0">
                 <a:solidFill>
                   <a:srgbClr val="080808"/>
                 </a:solidFill>
@@ -9651,7 +9651,7 @@
               <a:t>)</a:t>
             </a:r>
             <a:br>
-              <a:rPr lang="en-US" altLang="ko-KR" sz="1800" dirty="0">
+              <a:rPr lang="en-US" altLang="ko-KR" sz="1800" u="sng" dirty="0">
                 <a:solidFill>
                   <a:srgbClr val="080808"/>
                 </a:solidFill>
@@ -9661,7 +9661,7 @@
               </a:rPr>
             </a:br>
             <a:r>
-              <a:rPr lang="en-US" altLang="ko-KR" sz="1800" dirty="0">
+              <a:rPr lang="en-US" altLang="ko-KR" sz="1800" u="sng" dirty="0">
                 <a:solidFill>
                   <a:srgbClr val="080808"/>
                 </a:solidFill>
@@ -9672,7 +9672,7 @@
               <a:t>    }</a:t>
             </a:r>
             <a:br>
-              <a:rPr lang="en-US" altLang="ko-KR" sz="1800" dirty="0">
+              <a:rPr lang="en-US" altLang="ko-KR" sz="1800" u="sng" dirty="0">
                 <a:solidFill>
                   <a:srgbClr val="080808"/>
                 </a:solidFill>
@@ -9682,7 +9682,7 @@
               </a:rPr>
             </a:br>
             <a:r>
-              <a:rPr lang="en-US" altLang="ko-KR" sz="1800" dirty="0">
+              <a:rPr lang="en-US" altLang="ko-KR" sz="1800" u="sng" dirty="0">
                 <a:solidFill>
                   <a:srgbClr val="080808"/>
                 </a:solidFill>
@@ -9693,7 +9693,7 @@
               <a:t>}</a:t>
             </a:r>
             <a:br>
-              <a:rPr lang="en-US" altLang="ko-KR" sz="1800" dirty="0">
+              <a:rPr lang="en-US" altLang="ko-KR" sz="1800" u="sng" dirty="0">
                 <a:solidFill>
                   <a:srgbClr val="080808"/>
                 </a:solidFill>
@@ -9703,7 +9703,7 @@
               </a:rPr>
             </a:br>
             <a:r>
-              <a:rPr lang="en-US" altLang="ko-KR" sz="1800" i="1" dirty="0" err="1">
+              <a:rPr lang="en-US" altLang="ko-KR" sz="1800" i="1" u="sng" dirty="0" err="1">
                 <a:solidFill>
                   <a:srgbClr val="00627A"/>
                 </a:solidFill>
@@ -9714,7 +9714,7 @@
               <a:t>println</a:t>
             </a:r>
             <a:r>
-              <a:rPr lang="en-US" altLang="ko-KR" sz="1800" dirty="0">
+              <a:rPr lang="en-US" altLang="ko-KR" sz="1800" u="sng" dirty="0">
                 <a:solidFill>
                   <a:srgbClr val="080808"/>
                 </a:solidFill>
@@ -9725,7 +9725,7 @@
               <a:t>(</a:t>
             </a:r>
             <a:r>
-              <a:rPr lang="en-US" altLang="ko-KR" sz="1800" dirty="0">
+              <a:rPr lang="en-US" altLang="ko-KR" sz="1800" u="sng" dirty="0">
                 <a:solidFill>
                   <a:srgbClr val="000000"/>
                 </a:solidFill>
@@ -9736,7 +9736,7 @@
               <a:t>temp</a:t>
             </a:r>
             <a:r>
-              <a:rPr lang="en-US" altLang="ko-KR" sz="1800" dirty="0">
+              <a:rPr lang="en-US" altLang="ko-KR" sz="1800" u="sng" dirty="0">
                 <a:solidFill>
                   <a:srgbClr val="080808"/>
                 </a:solidFill>
@@ -9747,7 +9747,7 @@
               <a:t>)</a:t>
             </a:r>
             <a:br>
-              <a:rPr lang="en-US" altLang="ko-KR" sz="1800" dirty="0">
+              <a:rPr lang="en-US" altLang="ko-KR" sz="1800" u="sng" dirty="0">
                 <a:solidFill>
                   <a:srgbClr val="080808"/>
                 </a:solidFill>

</xml_diff>